<commit_message>
Include usage with interpreter in slide
</commit_message>
<xml_diff>
--- a/Observer/presentation/slide.pptx
+++ b/Observer/presentation/slide.pptx
@@ -5,10 +5,10 @@
     <p:sldMasterId id="2147483648" r:id="rId1"/>
   </p:sldMasterIdLst>
   <p:notesMasterIdLst>
-    <p:notesMasterId r:id="rId8"/>
+    <p:notesMasterId r:id="rId11"/>
   </p:notesMasterIdLst>
   <p:handoutMasterIdLst>
-    <p:handoutMasterId r:id="rId9"/>
+    <p:handoutMasterId r:id="rId12"/>
   </p:handoutMasterIdLst>
   <p:sldIdLst>
     <p:sldId id="417" r:id="rId2"/>
@@ -17,6 +17,9 @@
     <p:sldId id="420" r:id="rId5"/>
     <p:sldId id="421" r:id="rId6"/>
     <p:sldId id="422" r:id="rId7"/>
+    <p:sldId id="424" r:id="rId8"/>
+    <p:sldId id="425" r:id="rId9"/>
+    <p:sldId id="426" r:id="rId10"/>
   </p:sldIdLst>
   <p:sldSz cx="9906000" cy="6858000" type="A4"/>
   <p:notesSz cx="6718300" cy="9867900"/>
@@ -193,6 +196,33 @@
 </p:presentation>
 </file>
 
+<file path=ppt/authors.xml><?xml version="1.0" encoding="utf-8"?>
+<p188:authorLst xmlns:a="http://schemas.openxmlformats.org/drawingml/2006/main" xmlns:r="http://schemas.openxmlformats.org/officeDocument/2006/relationships" xmlns:p188="http://schemas.microsoft.com/office/powerpoint/2018/8/main">
+  <p188:author id="{BA267FB5-7580-E143-0B74-089C49A2450E}" name="TRẦN GIA HUY" initials="TH" userId="S::2512508415@student.hcmus.edu.vn::2afa8d98-0824-47de-b27b-39e5cae4f870" providerId="AD"/>
+</p188:authorLst>
+</file>
+
+<file path=ppt/comments/modernComment_1A8_E8F010D0.xml><?xml version="1.0" encoding="utf-8"?>
+<p188:cmLst xmlns:a="http://schemas.openxmlformats.org/drawingml/2006/main" xmlns:r="http://schemas.openxmlformats.org/officeDocument/2006/relationships" xmlns:p188="http://schemas.microsoft.com/office/powerpoint/2018/8/main">
+  <p188:cm id="{A8AD2A06-BB21-47BF-B1BA-D813FAF2E6C9}" authorId="{BA267FB5-7580-E143-0B74-089C49A2450E}" created="2026-07-15T08:13:50.653">
+    <pc:sldMkLst xmlns:pc="http://schemas.microsoft.com/office/powerpoint/2013/main/command">
+      <pc:docMk/>
+      <pc:sldMk cId="3908047056" sldId="424"/>
+    </pc:sldMkLst>
+    <p188:txBody>
+      <a:bodyPr/>
+      <a:lstStyle/>
+      <a:p>
+        <a:r>
+          <a:rPr lang="en-US"/>
+          <a:t>Start of section 7</a:t>
+        </a:r>
+      </a:p>
+    </p188:txBody>
+  </p188:cm>
+</p188:cmLst>
+</file>
+
 <file path=ppt/handoutMasters/handoutMaster1.xml><?xml version="1.0" encoding="utf-8"?>
 <p:handoutMaster xmlns:a="http://schemas.openxmlformats.org/drawingml/2006/main" xmlns:r="http://schemas.openxmlformats.org/officeDocument/2006/relationships" xmlns:p="http://schemas.openxmlformats.org/presentationml/2006/main">
   <p:cSld>
@@ -328,7 +358,7 @@
             </a:pPr>
             <a:fld id="{A94140A0-9A56-5344-A45C-C6AEC62A4163}" type="datetime1">
               <a:rPr lang="en-SG" smtClean="0"/>
-              <a:t>14/7/2026</a:t>
+              <a:t>15/7/2026</a:t>
             </a:fld>
             <a:endParaRPr lang="en-GB"/>
           </a:p>
@@ -633,7 +663,7 @@
             </a:pPr>
             <a:fld id="{4E637528-6EEA-2D41-869C-D32687B0D5B4}" type="datetime1">
               <a:rPr lang="en-SG" smtClean="0"/>
-              <a:t>14/7/2026</a:t>
+              <a:t>15/7/2026</a:t>
             </a:fld>
             <a:endParaRPr lang="en-US"/>
           </a:p>
@@ -1104,7 +1134,7 @@
             </a:pPr>
             <a:fld id="{E97A3520-1F26-804C-B4BE-87967715ADF3}" type="datetime1">
               <a:rPr lang="en-SG" smtClean="0"/>
-              <a:t>14/7/2026</a:t>
+              <a:t>15/7/2026</a:t>
             </a:fld>
             <a:endParaRPr lang="en-US" dirty="0"/>
           </a:p>
@@ -4984,7 +5014,7 @@
             <a:pPr algn="ctr"/>
             <a:r>
               <a:rPr lang="en-US" sz="3200" b="1" dirty="0"/>
-              <a:t>CS202 – Observer pattern</a:t>
+              <a:t>CS202 – Observer design pattern</a:t>
             </a:r>
           </a:p>
         </p:txBody>
@@ -5027,7 +5057,7 @@
             </a:r>
             <a:r>
               <a:rPr lang="en-US" sz="1600" b="1" dirty="0"/>
-              <a:t> Minh Huy - …</a:t>
+              <a:t> Minh Huy - 25125083</a:t>
             </a:r>
           </a:p>
           <a:p>
@@ -5141,7 +5171,7 @@
         <p:spPr>
           <a:xfrm>
             <a:off x="782506" y="1928812"/>
-            <a:ext cx="8420100" cy="3023015"/>
+            <a:ext cx="8420100" cy="3370775"/>
           </a:xfrm>
         </p:spPr>
         <p:txBody>
@@ -5199,6 +5229,15 @@
             <a:r>
               <a:rPr lang="en-US" dirty="0"/>
               <a:t>Pros &amp; Cons</a:t>
+            </a:r>
+          </a:p>
+          <a:p>
+            <a:pPr marL="457200" indent="-457200">
+              <a:buAutoNum type="arabicPeriod"/>
+            </a:pPr>
+            <a:r>
+              <a:rPr lang="en-US" dirty="0"/>
+              <a:t>Relationship with Interpreter and Mediator design pattern</a:t>
             </a:r>
           </a:p>
           <a:p>
@@ -6063,6 +6102,1045 @@
     <p:extLst>
       <p:ext uri="{BB962C8B-B14F-4D97-AF65-F5344CB8AC3E}">
         <p14:creationId xmlns:p14="http://schemas.microsoft.com/office/powerpoint/2010/main" val="2853783875"/>
+      </p:ext>
+    </p:extLst>
+  </p:cSld>
+  <p:clrMapOvr>
+    <a:masterClrMapping/>
+  </p:clrMapOvr>
+</p:sld>
+</file>
+
+<file path=ppt/slides/slide7.xml><?xml version="1.0" encoding="utf-8"?>
+<p:sld xmlns:a="http://schemas.openxmlformats.org/drawingml/2006/main" xmlns:r="http://schemas.openxmlformats.org/officeDocument/2006/relationships" xmlns:p="http://schemas.openxmlformats.org/presentationml/2006/main">
+  <p:cSld>
+    <p:spTree>
+      <p:nvGrpSpPr>
+        <p:cNvPr id="1" name="">
+          <a:extLst>
+            <a:ext uri="{FF2B5EF4-FFF2-40B4-BE49-F238E27FC236}">
+              <a16:creationId xmlns:a16="http://schemas.microsoft.com/office/drawing/2014/main" id="{AE2E23BA-695D-7D1C-37C8-88A3CFCCA612}"/>
+            </a:ext>
+          </a:extLst>
+        </p:cNvPr>
+        <p:cNvGrpSpPr/>
+        <p:nvPr/>
+      </p:nvGrpSpPr>
+      <p:grpSpPr>
+        <a:xfrm>
+          <a:off x="0" y="0"/>
+          <a:ext cx="0" cy="0"/>
+          <a:chOff x="0" y="0"/>
+          <a:chExt cx="0" cy="0"/>
+        </a:xfrm>
+      </p:grpSpPr>
+      <p:sp>
+        <p:nvSpPr>
+          <p:cNvPr id="2" name="Title 1">
+            <a:extLst>
+              <a:ext uri="{FF2B5EF4-FFF2-40B4-BE49-F238E27FC236}">
+                <a16:creationId xmlns:a16="http://schemas.microsoft.com/office/drawing/2014/main" id="{74406926-CBBE-CF2F-AA61-C5669C48545F}"/>
+              </a:ext>
+            </a:extLst>
+          </p:cNvPr>
+          <p:cNvSpPr>
+            <a:spLocks noGrp="1"/>
+          </p:cNvSpPr>
+          <p:nvPr>
+            <p:ph type="title"/>
+          </p:nvPr>
+        </p:nvSpPr>
+        <p:spPr>
+          <a:xfrm>
+            <a:off x="742950" y="802688"/>
+            <a:ext cx="8420100" cy="1399738"/>
+          </a:xfrm>
+        </p:spPr>
+        <p:txBody>
+          <a:bodyPr/>
+          <a:lstStyle/>
+          <a:p>
+            <a:r>
+              <a:rPr lang="en-US" cap="none" dirty="0"/>
+              <a:t>Relationship with Interpreter design pattern</a:t>
+            </a:r>
+          </a:p>
+        </p:txBody>
+      </p:sp>
+      <p:sp>
+        <p:nvSpPr>
+          <p:cNvPr id="4" name="Footer Placeholder 3">
+            <a:extLst>
+              <a:ext uri="{FF2B5EF4-FFF2-40B4-BE49-F238E27FC236}">
+                <a16:creationId xmlns:a16="http://schemas.microsoft.com/office/drawing/2014/main" id="{F6766942-2154-9D37-0652-AC9E6477A733}"/>
+              </a:ext>
+            </a:extLst>
+          </p:cNvPr>
+          <p:cNvSpPr>
+            <a:spLocks noGrp="1"/>
+          </p:cNvSpPr>
+          <p:nvPr>
+            <p:ph type="ftr" sz="quarter" idx="10"/>
+          </p:nvPr>
+        </p:nvSpPr>
+        <p:spPr/>
+        <p:txBody>
+          <a:bodyPr/>
+          <a:lstStyle/>
+          <a:p>
+            <a:pPr>
+              <a:defRPr/>
+            </a:pPr>
+            <a:r>
+              <a:rPr lang="en-GB"/>
+              <a:t>Copyright © University of Science, VNUHCM - APCS 2023</a:t>
+            </a:r>
+          </a:p>
+        </p:txBody>
+      </p:sp>
+      <p:sp>
+        <p:nvSpPr>
+          <p:cNvPr id="11" name="Text Placeholder 2">
+            <a:extLst>
+              <a:ext uri="{FF2B5EF4-FFF2-40B4-BE49-F238E27FC236}">
+                <a16:creationId xmlns:a16="http://schemas.microsoft.com/office/drawing/2014/main" id="{94209340-E929-DFFB-F2C2-ED6F2C1BA8F8}"/>
+              </a:ext>
+            </a:extLst>
+          </p:cNvPr>
+          <p:cNvSpPr>
+            <a:spLocks noGrp="1"/>
+          </p:cNvSpPr>
+          <p:nvPr>
+            <p:ph type="body" idx="1"/>
+          </p:nvPr>
+        </p:nvSpPr>
+        <p:spPr>
+          <a:xfrm>
+            <a:off x="742950" y="2202426"/>
+            <a:ext cx="4210049" cy="1956619"/>
+          </a:xfrm>
+        </p:spPr>
+        <p:txBody>
+          <a:bodyPr anchor="t"/>
+          <a:lstStyle/>
+          <a:p>
+            <a:r>
+              <a:rPr lang="en-US" dirty="0"/>
+              <a:t>Interpreter design pattern: Given a language, we need to defined a hierarchical representation for the language.</a:t>
+            </a:r>
+          </a:p>
+          <a:p>
+            <a:r>
+              <a:rPr lang="en-US" dirty="0"/>
+              <a:t>Example: Representing (5 + 1) x 10 + 41 - x as an operation tree.</a:t>
+            </a:r>
+          </a:p>
+          <a:p>
+            <a:endParaRPr lang="en-US" dirty="0"/>
+          </a:p>
+        </p:txBody>
+      </p:sp>
+      <p:pic>
+        <p:nvPicPr>
+          <p:cNvPr id="5" name="Picture 4">
+            <a:extLst>
+              <a:ext uri="{FF2B5EF4-FFF2-40B4-BE49-F238E27FC236}">
+                <a16:creationId xmlns:a16="http://schemas.microsoft.com/office/drawing/2014/main" id="{0DD96C78-751B-DC81-2FA5-A69489DE9099}"/>
+              </a:ext>
+            </a:extLst>
+          </p:cNvPr>
+          <p:cNvPicPr>
+            <a:picLocks noChangeAspect="1"/>
+          </p:cNvPicPr>
+          <p:nvPr/>
+        </p:nvPicPr>
+        <p:blipFill>
+          <a:blip r:embed="rId3"/>
+          <a:stretch>
+            <a:fillRect/>
+          </a:stretch>
+        </p:blipFill>
+        <p:spPr>
+          <a:xfrm>
+            <a:off x="4953001" y="2202426"/>
+            <a:ext cx="4445662" cy="2916637"/>
+          </a:xfrm>
+          <a:prstGeom prst="rect">
+            <a:avLst/>
+          </a:prstGeom>
+        </p:spPr>
+      </p:pic>
+      <p:sp>
+        <p:nvSpPr>
+          <p:cNvPr id="6" name="Text Placeholder 2">
+            <a:extLst>
+              <a:ext uri="{FF2B5EF4-FFF2-40B4-BE49-F238E27FC236}">
+                <a16:creationId xmlns:a16="http://schemas.microsoft.com/office/drawing/2014/main" id="{7C9E8FCA-4CE8-6DC4-89B1-CA25B9246C94}"/>
+              </a:ext>
+            </a:extLst>
+          </p:cNvPr>
+          <p:cNvSpPr txBox="1">
+            <a:spLocks/>
+          </p:cNvSpPr>
+          <p:nvPr/>
+        </p:nvSpPr>
+        <p:spPr bwMode="auto">
+          <a:xfrm>
+            <a:off x="4952999" y="5119063"/>
+            <a:ext cx="4445662" cy="261913"/>
+          </a:xfrm>
+          <a:prstGeom prst="rect">
+            <a:avLst/>
+          </a:prstGeom>
+          <a:noFill/>
+          <a:ln w="9525">
+            <a:noFill/>
+            <a:miter lim="800000"/>
+            <a:headEnd/>
+            <a:tailEnd/>
+          </a:ln>
+        </p:spPr>
+        <p:txBody>
+          <a:bodyPr vert="horz" wrap="square" lIns="91440" tIns="45720" rIns="91440" bIns="45720" numCol="1" anchor="t" anchorCtr="0" compatLnSpc="1">
+            <a:prstTxWarp prst="textNoShape">
+              <a:avLst/>
+            </a:prstTxWarp>
+          </a:bodyPr>
+          <a:lstStyle>
+            <a:lvl1pPr marL="0" indent="0" algn="l" rtl="0" eaLnBrk="0" fontAlgn="base" hangingPunct="0">
+              <a:spcBef>
+                <a:spcPct val="20000"/>
+              </a:spcBef>
+              <a:spcAft>
+                <a:spcPct val="0"/>
+              </a:spcAft>
+              <a:buNone/>
+              <a:defRPr sz="2000">
+                <a:solidFill>
+                  <a:schemeClr val="tx1"/>
+                </a:solidFill>
+                <a:latin typeface="+mn-lt"/>
+                <a:ea typeface="+mn-ea"/>
+                <a:cs typeface="+mn-cs"/>
+              </a:defRPr>
+            </a:lvl1pPr>
+            <a:lvl2pPr marL="457200" indent="0" algn="l" rtl="0" eaLnBrk="0" fontAlgn="base" hangingPunct="0">
+              <a:spcBef>
+                <a:spcPct val="20000"/>
+              </a:spcBef>
+              <a:spcAft>
+                <a:spcPct val="0"/>
+              </a:spcAft>
+              <a:buNone/>
+              <a:defRPr sz="1800">
+                <a:solidFill>
+                  <a:schemeClr val="tx1"/>
+                </a:solidFill>
+                <a:latin typeface="+mn-lt"/>
+                <a:ea typeface="+mn-ea"/>
+              </a:defRPr>
+            </a:lvl2pPr>
+            <a:lvl3pPr marL="914400" indent="0" algn="l" rtl="0" eaLnBrk="0" fontAlgn="base" hangingPunct="0">
+              <a:spcBef>
+                <a:spcPct val="20000"/>
+              </a:spcBef>
+              <a:spcAft>
+                <a:spcPct val="0"/>
+              </a:spcAft>
+              <a:buNone/>
+              <a:defRPr sz="1600">
+                <a:solidFill>
+                  <a:schemeClr val="tx1"/>
+                </a:solidFill>
+                <a:latin typeface="+mn-lt"/>
+                <a:ea typeface="+mn-ea"/>
+              </a:defRPr>
+            </a:lvl3pPr>
+            <a:lvl4pPr marL="1371600" indent="0" algn="l" rtl="0" eaLnBrk="0" fontAlgn="base" hangingPunct="0">
+              <a:spcBef>
+                <a:spcPct val="20000"/>
+              </a:spcBef>
+              <a:spcAft>
+                <a:spcPct val="0"/>
+              </a:spcAft>
+              <a:buNone/>
+              <a:defRPr sz="1400">
+                <a:solidFill>
+                  <a:schemeClr val="tx1"/>
+                </a:solidFill>
+                <a:latin typeface="+mn-lt"/>
+                <a:ea typeface="+mn-ea"/>
+              </a:defRPr>
+            </a:lvl4pPr>
+            <a:lvl5pPr marL="1828800" indent="0" algn="l" rtl="0" eaLnBrk="0" fontAlgn="base" hangingPunct="0">
+              <a:spcBef>
+                <a:spcPct val="20000"/>
+              </a:spcBef>
+              <a:spcAft>
+                <a:spcPct val="0"/>
+              </a:spcAft>
+              <a:buNone/>
+              <a:defRPr sz="1400">
+                <a:solidFill>
+                  <a:schemeClr val="tx1"/>
+                </a:solidFill>
+                <a:latin typeface="+mn-lt"/>
+                <a:ea typeface="+mn-ea"/>
+              </a:defRPr>
+            </a:lvl5pPr>
+            <a:lvl6pPr marL="2286000" indent="0" algn="l" rtl="0" fontAlgn="base">
+              <a:spcBef>
+                <a:spcPct val="20000"/>
+              </a:spcBef>
+              <a:spcAft>
+                <a:spcPct val="0"/>
+              </a:spcAft>
+              <a:buNone/>
+              <a:defRPr sz="1400">
+                <a:solidFill>
+                  <a:schemeClr val="tx1"/>
+                </a:solidFill>
+                <a:latin typeface="+mn-lt"/>
+                <a:ea typeface="+mn-ea"/>
+              </a:defRPr>
+            </a:lvl6pPr>
+            <a:lvl7pPr marL="2743200" indent="0" algn="l" rtl="0" fontAlgn="base">
+              <a:spcBef>
+                <a:spcPct val="20000"/>
+              </a:spcBef>
+              <a:spcAft>
+                <a:spcPct val="0"/>
+              </a:spcAft>
+              <a:buNone/>
+              <a:defRPr sz="1400">
+                <a:solidFill>
+                  <a:schemeClr val="tx1"/>
+                </a:solidFill>
+                <a:latin typeface="+mn-lt"/>
+                <a:ea typeface="+mn-ea"/>
+              </a:defRPr>
+            </a:lvl7pPr>
+            <a:lvl8pPr marL="3200400" indent="0" algn="l" rtl="0" fontAlgn="base">
+              <a:spcBef>
+                <a:spcPct val="20000"/>
+              </a:spcBef>
+              <a:spcAft>
+                <a:spcPct val="0"/>
+              </a:spcAft>
+              <a:buNone/>
+              <a:defRPr sz="1400">
+                <a:solidFill>
+                  <a:schemeClr val="tx1"/>
+                </a:solidFill>
+                <a:latin typeface="+mn-lt"/>
+                <a:ea typeface="+mn-ea"/>
+              </a:defRPr>
+            </a:lvl8pPr>
+            <a:lvl9pPr marL="3657600" indent="0" algn="l" rtl="0" fontAlgn="base">
+              <a:spcBef>
+                <a:spcPct val="20000"/>
+              </a:spcBef>
+              <a:spcAft>
+                <a:spcPct val="0"/>
+              </a:spcAft>
+              <a:buNone/>
+              <a:defRPr sz="1400">
+                <a:solidFill>
+                  <a:schemeClr val="tx1"/>
+                </a:solidFill>
+                <a:latin typeface="+mn-lt"/>
+                <a:ea typeface="+mn-ea"/>
+              </a:defRPr>
+            </a:lvl9pPr>
+          </a:lstStyle>
+          <a:p>
+            <a:pPr algn="ctr">
+              <a:lnSpc>
+                <a:spcPct val="100000"/>
+              </a:lnSpc>
+            </a:pPr>
+            <a:r>
+              <a:rPr lang="en-US" sz="1200" kern="0" dirty="0"/>
+              <a:t>Source: https://sourcemaking.com/</a:t>
+            </a:r>
+          </a:p>
+          <a:p>
+            <a:pPr algn="ctr">
+              <a:lnSpc>
+                <a:spcPct val="100000"/>
+              </a:lnSpc>
+            </a:pPr>
+            <a:endParaRPr lang="en-US" sz="1200" kern="0" dirty="0"/>
+          </a:p>
+        </p:txBody>
+      </p:sp>
+    </p:spTree>
+    <p:extLst>
+      <p:ext uri="{BB962C8B-B14F-4D97-AF65-F5344CB8AC3E}">
+        <p14:creationId xmlns:p14="http://schemas.microsoft.com/office/powerpoint/2010/main" val="3908047056"/>
+      </p:ext>
+    </p:extLst>
+  </p:cSld>
+  <p:clrMapOvr>
+    <a:masterClrMapping/>
+  </p:clrMapOvr>
+  <p:extLst>
+    <p:ext uri="{6950BFC3-D8DA-4A85-94F7-54DA5524770B}">
+      <p188:commentRel xmlns:p188="http://schemas.microsoft.com/office/powerpoint/2018/8/main" r:id="rId2"/>
+    </p:ext>
+  </p:extLst>
+</p:sld>
+</file>
+
+<file path=ppt/slides/slide8.xml><?xml version="1.0" encoding="utf-8"?>
+<p:sld xmlns:a="http://schemas.openxmlformats.org/drawingml/2006/main" xmlns:r="http://schemas.openxmlformats.org/officeDocument/2006/relationships" xmlns:p="http://schemas.openxmlformats.org/presentationml/2006/main">
+  <p:cSld>
+    <p:spTree>
+      <p:nvGrpSpPr>
+        <p:cNvPr id="1" name="">
+          <a:extLst>
+            <a:ext uri="{FF2B5EF4-FFF2-40B4-BE49-F238E27FC236}">
+              <a16:creationId xmlns:a16="http://schemas.microsoft.com/office/drawing/2014/main" id="{6423CBB7-C487-C1A5-2124-A8E74E72B279}"/>
+            </a:ext>
+          </a:extLst>
+        </p:cNvPr>
+        <p:cNvGrpSpPr/>
+        <p:nvPr/>
+      </p:nvGrpSpPr>
+      <p:grpSpPr>
+        <a:xfrm>
+          <a:off x="0" y="0"/>
+          <a:ext cx="0" cy="0"/>
+          <a:chOff x="0" y="0"/>
+          <a:chExt cx="0" cy="0"/>
+        </a:xfrm>
+      </p:grpSpPr>
+      <p:sp>
+        <p:nvSpPr>
+          <p:cNvPr id="2" name="Title 1">
+            <a:extLst>
+              <a:ext uri="{FF2B5EF4-FFF2-40B4-BE49-F238E27FC236}">
+                <a16:creationId xmlns:a16="http://schemas.microsoft.com/office/drawing/2014/main" id="{1E30F6DE-A1F4-AF00-C3A5-49A4328B07EB}"/>
+              </a:ext>
+            </a:extLst>
+          </p:cNvPr>
+          <p:cNvSpPr>
+            <a:spLocks noGrp="1"/>
+          </p:cNvSpPr>
+          <p:nvPr>
+            <p:ph type="title"/>
+          </p:nvPr>
+        </p:nvSpPr>
+        <p:spPr>
+          <a:xfrm>
+            <a:off x="742950" y="802688"/>
+            <a:ext cx="8420100" cy="1399738"/>
+          </a:xfrm>
+        </p:spPr>
+        <p:txBody>
+          <a:bodyPr/>
+          <a:lstStyle/>
+          <a:p>
+            <a:r>
+              <a:rPr lang="en-US" cap="none" dirty="0"/>
+              <a:t>Relationship with Interpreter design pattern</a:t>
+            </a:r>
+          </a:p>
+        </p:txBody>
+      </p:sp>
+      <p:sp>
+        <p:nvSpPr>
+          <p:cNvPr id="4" name="Footer Placeholder 3">
+            <a:extLst>
+              <a:ext uri="{FF2B5EF4-FFF2-40B4-BE49-F238E27FC236}">
+                <a16:creationId xmlns:a16="http://schemas.microsoft.com/office/drawing/2014/main" id="{DBE556FD-4732-DA68-C715-23C11308E44C}"/>
+              </a:ext>
+            </a:extLst>
+          </p:cNvPr>
+          <p:cNvSpPr>
+            <a:spLocks noGrp="1"/>
+          </p:cNvSpPr>
+          <p:nvPr>
+            <p:ph type="ftr" sz="quarter" idx="10"/>
+          </p:nvPr>
+        </p:nvSpPr>
+        <p:spPr/>
+        <p:txBody>
+          <a:bodyPr/>
+          <a:lstStyle/>
+          <a:p>
+            <a:pPr>
+              <a:defRPr/>
+            </a:pPr>
+            <a:r>
+              <a:rPr lang="en-GB"/>
+              <a:t>Copyright © University of Science, VNUHCM - APCS 2023</a:t>
+            </a:r>
+          </a:p>
+        </p:txBody>
+      </p:sp>
+      <p:sp>
+        <p:nvSpPr>
+          <p:cNvPr id="11" name="Text Placeholder 2">
+            <a:extLst>
+              <a:ext uri="{FF2B5EF4-FFF2-40B4-BE49-F238E27FC236}">
+                <a16:creationId xmlns:a16="http://schemas.microsoft.com/office/drawing/2014/main" id="{E1BBEA7B-77EF-861C-2314-5D8DCAC536A0}"/>
+              </a:ext>
+            </a:extLst>
+          </p:cNvPr>
+          <p:cNvSpPr>
+            <a:spLocks noGrp="1"/>
+          </p:cNvSpPr>
+          <p:nvPr>
+            <p:ph type="body" idx="1"/>
+          </p:nvPr>
+        </p:nvSpPr>
+        <p:spPr>
+          <a:xfrm>
+            <a:off x="742950" y="2202426"/>
+            <a:ext cx="8420100" cy="1052051"/>
+          </a:xfrm>
+        </p:spPr>
+        <p:txBody>
+          <a:bodyPr anchor="t"/>
+          <a:lstStyle/>
+          <a:p>
+            <a:r>
+              <a:rPr lang="en-US" dirty="0"/>
+              <a:t>However, if the terminal expression is a variable, which can be changed by another process, services, … instead of being a constant, then we need to update the result of the operations according to the new value.</a:t>
+            </a:r>
+          </a:p>
+        </p:txBody>
+      </p:sp>
+      <p:sp>
+        <p:nvSpPr>
+          <p:cNvPr id="3" name="Text Placeholder 2">
+            <a:extLst>
+              <a:ext uri="{FF2B5EF4-FFF2-40B4-BE49-F238E27FC236}">
+                <a16:creationId xmlns:a16="http://schemas.microsoft.com/office/drawing/2014/main" id="{D2F16AD8-86F0-BA07-5433-BA82D08065C1}"/>
+              </a:ext>
+            </a:extLst>
+          </p:cNvPr>
+          <p:cNvSpPr txBox="1">
+            <a:spLocks/>
+          </p:cNvSpPr>
+          <p:nvPr/>
+        </p:nvSpPr>
+        <p:spPr bwMode="auto">
+          <a:xfrm>
+            <a:off x="742950" y="3602164"/>
+            <a:ext cx="8420100" cy="746354"/>
+          </a:xfrm>
+          <a:prstGeom prst="rect">
+            <a:avLst/>
+          </a:prstGeom>
+          <a:noFill/>
+          <a:ln w="9525">
+            <a:noFill/>
+            <a:miter lim="800000"/>
+            <a:headEnd/>
+            <a:tailEnd/>
+          </a:ln>
+        </p:spPr>
+        <p:txBody>
+          <a:bodyPr vert="horz" wrap="square" lIns="91440" tIns="45720" rIns="91440" bIns="45720" numCol="1" anchor="t" anchorCtr="0" compatLnSpc="1">
+            <a:prstTxWarp prst="textNoShape">
+              <a:avLst/>
+            </a:prstTxWarp>
+          </a:bodyPr>
+          <a:lstStyle>
+            <a:lvl1pPr marL="0" indent="0" algn="l" rtl="0" eaLnBrk="0" fontAlgn="base" hangingPunct="0">
+              <a:spcBef>
+                <a:spcPct val="20000"/>
+              </a:spcBef>
+              <a:spcAft>
+                <a:spcPct val="0"/>
+              </a:spcAft>
+              <a:buNone/>
+              <a:defRPr sz="2000">
+                <a:solidFill>
+                  <a:schemeClr val="tx1"/>
+                </a:solidFill>
+                <a:latin typeface="+mn-lt"/>
+                <a:ea typeface="+mn-ea"/>
+                <a:cs typeface="+mn-cs"/>
+              </a:defRPr>
+            </a:lvl1pPr>
+            <a:lvl2pPr marL="457200" indent="0" algn="l" rtl="0" eaLnBrk="0" fontAlgn="base" hangingPunct="0">
+              <a:spcBef>
+                <a:spcPct val="20000"/>
+              </a:spcBef>
+              <a:spcAft>
+                <a:spcPct val="0"/>
+              </a:spcAft>
+              <a:buNone/>
+              <a:defRPr sz="1800">
+                <a:solidFill>
+                  <a:schemeClr val="tx1"/>
+                </a:solidFill>
+                <a:latin typeface="+mn-lt"/>
+                <a:ea typeface="+mn-ea"/>
+              </a:defRPr>
+            </a:lvl2pPr>
+            <a:lvl3pPr marL="914400" indent="0" algn="l" rtl="0" eaLnBrk="0" fontAlgn="base" hangingPunct="0">
+              <a:spcBef>
+                <a:spcPct val="20000"/>
+              </a:spcBef>
+              <a:spcAft>
+                <a:spcPct val="0"/>
+              </a:spcAft>
+              <a:buNone/>
+              <a:defRPr sz="1600">
+                <a:solidFill>
+                  <a:schemeClr val="tx1"/>
+                </a:solidFill>
+                <a:latin typeface="+mn-lt"/>
+                <a:ea typeface="+mn-ea"/>
+              </a:defRPr>
+            </a:lvl3pPr>
+            <a:lvl4pPr marL="1371600" indent="0" algn="l" rtl="0" eaLnBrk="0" fontAlgn="base" hangingPunct="0">
+              <a:spcBef>
+                <a:spcPct val="20000"/>
+              </a:spcBef>
+              <a:spcAft>
+                <a:spcPct val="0"/>
+              </a:spcAft>
+              <a:buNone/>
+              <a:defRPr sz="1400">
+                <a:solidFill>
+                  <a:schemeClr val="tx1"/>
+                </a:solidFill>
+                <a:latin typeface="+mn-lt"/>
+                <a:ea typeface="+mn-ea"/>
+              </a:defRPr>
+            </a:lvl4pPr>
+            <a:lvl5pPr marL="1828800" indent="0" algn="l" rtl="0" eaLnBrk="0" fontAlgn="base" hangingPunct="0">
+              <a:spcBef>
+                <a:spcPct val="20000"/>
+              </a:spcBef>
+              <a:spcAft>
+                <a:spcPct val="0"/>
+              </a:spcAft>
+              <a:buNone/>
+              <a:defRPr sz="1400">
+                <a:solidFill>
+                  <a:schemeClr val="tx1"/>
+                </a:solidFill>
+                <a:latin typeface="+mn-lt"/>
+                <a:ea typeface="+mn-ea"/>
+              </a:defRPr>
+            </a:lvl5pPr>
+            <a:lvl6pPr marL="2286000" indent="0" algn="l" rtl="0" fontAlgn="base">
+              <a:spcBef>
+                <a:spcPct val="20000"/>
+              </a:spcBef>
+              <a:spcAft>
+                <a:spcPct val="0"/>
+              </a:spcAft>
+              <a:buNone/>
+              <a:defRPr sz="1400">
+                <a:solidFill>
+                  <a:schemeClr val="tx1"/>
+                </a:solidFill>
+                <a:latin typeface="+mn-lt"/>
+                <a:ea typeface="+mn-ea"/>
+              </a:defRPr>
+            </a:lvl6pPr>
+            <a:lvl7pPr marL="2743200" indent="0" algn="l" rtl="0" fontAlgn="base">
+              <a:spcBef>
+                <a:spcPct val="20000"/>
+              </a:spcBef>
+              <a:spcAft>
+                <a:spcPct val="0"/>
+              </a:spcAft>
+              <a:buNone/>
+              <a:defRPr sz="1400">
+                <a:solidFill>
+                  <a:schemeClr val="tx1"/>
+                </a:solidFill>
+                <a:latin typeface="+mn-lt"/>
+                <a:ea typeface="+mn-ea"/>
+              </a:defRPr>
+            </a:lvl7pPr>
+            <a:lvl8pPr marL="3200400" indent="0" algn="l" rtl="0" fontAlgn="base">
+              <a:spcBef>
+                <a:spcPct val="20000"/>
+              </a:spcBef>
+              <a:spcAft>
+                <a:spcPct val="0"/>
+              </a:spcAft>
+              <a:buNone/>
+              <a:defRPr sz="1400">
+                <a:solidFill>
+                  <a:schemeClr val="tx1"/>
+                </a:solidFill>
+                <a:latin typeface="+mn-lt"/>
+                <a:ea typeface="+mn-ea"/>
+              </a:defRPr>
+            </a:lvl8pPr>
+            <a:lvl9pPr marL="3657600" indent="0" algn="l" rtl="0" fontAlgn="base">
+              <a:spcBef>
+                <a:spcPct val="20000"/>
+              </a:spcBef>
+              <a:spcAft>
+                <a:spcPct val="0"/>
+              </a:spcAft>
+              <a:buNone/>
+              <a:defRPr sz="1400">
+                <a:solidFill>
+                  <a:schemeClr val="tx1"/>
+                </a:solidFill>
+                <a:latin typeface="+mn-lt"/>
+                <a:ea typeface="+mn-ea"/>
+              </a:defRPr>
+            </a:lvl9pPr>
+          </a:lstStyle>
+          <a:p>
+            <a:pPr>
+              <a:lnSpc>
+                <a:spcPct val="100000"/>
+              </a:lnSpc>
+            </a:pPr>
+            <a:r>
+              <a:rPr lang="en-US" kern="0" dirty="0"/>
+              <a:t>=&gt; We use observer pattern to observe the changes in the variable and update the tree accordingly.</a:t>
+            </a:r>
+          </a:p>
+        </p:txBody>
+      </p:sp>
+    </p:spTree>
+    <p:extLst>
+      <p:ext uri="{BB962C8B-B14F-4D97-AF65-F5344CB8AC3E}">
+        <p14:creationId xmlns:p14="http://schemas.microsoft.com/office/powerpoint/2010/main" val="2012501073"/>
+      </p:ext>
+    </p:extLst>
+  </p:cSld>
+  <p:clrMapOvr>
+    <a:masterClrMapping/>
+  </p:clrMapOvr>
+</p:sld>
+</file>
+
+<file path=ppt/slides/slide9.xml><?xml version="1.0" encoding="utf-8"?>
+<p:sld xmlns:a="http://schemas.openxmlformats.org/drawingml/2006/main" xmlns:r="http://schemas.openxmlformats.org/officeDocument/2006/relationships" xmlns:p="http://schemas.openxmlformats.org/presentationml/2006/main">
+  <p:cSld>
+    <p:spTree>
+      <p:nvGrpSpPr>
+        <p:cNvPr id="1" name="">
+          <a:extLst>
+            <a:ext uri="{FF2B5EF4-FFF2-40B4-BE49-F238E27FC236}">
+              <a16:creationId xmlns:a16="http://schemas.microsoft.com/office/drawing/2014/main" id="{0D3AED65-414B-8096-5901-EB9B1AD65AB0}"/>
+            </a:ext>
+          </a:extLst>
+        </p:cNvPr>
+        <p:cNvGrpSpPr/>
+        <p:nvPr/>
+      </p:nvGrpSpPr>
+      <p:grpSpPr>
+        <a:xfrm>
+          <a:off x="0" y="0"/>
+          <a:ext cx="0" cy="0"/>
+          <a:chOff x="0" y="0"/>
+          <a:chExt cx="0" cy="0"/>
+        </a:xfrm>
+      </p:grpSpPr>
+      <p:sp>
+        <p:nvSpPr>
+          <p:cNvPr id="2" name="Title 1">
+            <a:extLst>
+              <a:ext uri="{FF2B5EF4-FFF2-40B4-BE49-F238E27FC236}">
+                <a16:creationId xmlns:a16="http://schemas.microsoft.com/office/drawing/2014/main" id="{B555AB08-B719-CD1D-2C7D-9EB97FB18548}"/>
+              </a:ext>
+            </a:extLst>
+          </p:cNvPr>
+          <p:cNvSpPr>
+            <a:spLocks noGrp="1"/>
+          </p:cNvSpPr>
+          <p:nvPr>
+            <p:ph type="title"/>
+          </p:nvPr>
+        </p:nvSpPr>
+        <p:spPr>
+          <a:xfrm>
+            <a:off x="742950" y="802688"/>
+            <a:ext cx="8420100" cy="1399738"/>
+          </a:xfrm>
+        </p:spPr>
+        <p:txBody>
+          <a:bodyPr/>
+          <a:lstStyle/>
+          <a:p>
+            <a:r>
+              <a:rPr lang="en-US" cap="none" dirty="0"/>
+              <a:t>Relationship with Interpreter design pattern</a:t>
+            </a:r>
+          </a:p>
+        </p:txBody>
+      </p:sp>
+      <p:sp>
+        <p:nvSpPr>
+          <p:cNvPr id="4" name="Footer Placeholder 3">
+            <a:extLst>
+              <a:ext uri="{FF2B5EF4-FFF2-40B4-BE49-F238E27FC236}">
+                <a16:creationId xmlns:a16="http://schemas.microsoft.com/office/drawing/2014/main" id="{079F7CFD-2067-C7B3-3039-BC106FC0EEA4}"/>
+              </a:ext>
+            </a:extLst>
+          </p:cNvPr>
+          <p:cNvSpPr>
+            <a:spLocks noGrp="1"/>
+          </p:cNvSpPr>
+          <p:nvPr>
+            <p:ph type="ftr" sz="quarter" idx="10"/>
+          </p:nvPr>
+        </p:nvSpPr>
+        <p:spPr/>
+        <p:txBody>
+          <a:bodyPr/>
+          <a:lstStyle/>
+          <a:p>
+            <a:pPr>
+              <a:defRPr/>
+            </a:pPr>
+            <a:r>
+              <a:rPr lang="en-GB"/>
+              <a:t>Copyright © University of Science, VNUHCM - APCS 2023</a:t>
+            </a:r>
+          </a:p>
+        </p:txBody>
+      </p:sp>
+      <p:sp>
+        <p:nvSpPr>
+          <p:cNvPr id="11" name="Text Placeholder 2">
+            <a:extLst>
+              <a:ext uri="{FF2B5EF4-FFF2-40B4-BE49-F238E27FC236}">
+                <a16:creationId xmlns:a16="http://schemas.microsoft.com/office/drawing/2014/main" id="{00084408-9B21-DCA4-12A2-43C252AF7E4A}"/>
+              </a:ext>
+            </a:extLst>
+          </p:cNvPr>
+          <p:cNvSpPr>
+            <a:spLocks noGrp="1"/>
+          </p:cNvSpPr>
+          <p:nvPr>
+            <p:ph type="body" idx="1"/>
+          </p:nvPr>
+        </p:nvSpPr>
+        <p:spPr>
+          <a:xfrm>
+            <a:off x="742950" y="2202427"/>
+            <a:ext cx="8420100" cy="1061884"/>
+          </a:xfrm>
+        </p:spPr>
+        <p:txBody>
+          <a:bodyPr anchor="t"/>
+          <a:lstStyle/>
+          <a:p>
+            <a:r>
+              <a:rPr lang="en-US" dirty="0"/>
+              <a:t>Example: We have a spreadsheet (like an Excel file). In cell A3, we have a formula “= A1 + A2”. The result of A3 depends on the result of A1 and A2, which can be changed by another formula(s) or by user.</a:t>
+            </a:r>
+          </a:p>
+        </p:txBody>
+      </p:sp>
+      <p:sp>
+        <p:nvSpPr>
+          <p:cNvPr id="6" name="Text Placeholder 2">
+            <a:extLst>
+              <a:ext uri="{FF2B5EF4-FFF2-40B4-BE49-F238E27FC236}">
+                <a16:creationId xmlns:a16="http://schemas.microsoft.com/office/drawing/2014/main" id="{C72A18CB-294B-4849-A59E-06122C70C6D5}"/>
+              </a:ext>
+            </a:extLst>
+          </p:cNvPr>
+          <p:cNvSpPr txBox="1">
+            <a:spLocks/>
+          </p:cNvSpPr>
+          <p:nvPr/>
+        </p:nvSpPr>
+        <p:spPr bwMode="auto">
+          <a:xfrm>
+            <a:off x="742950" y="3593690"/>
+            <a:ext cx="8420100" cy="771832"/>
+          </a:xfrm>
+          <a:prstGeom prst="rect">
+            <a:avLst/>
+          </a:prstGeom>
+          <a:noFill/>
+          <a:ln w="9525">
+            <a:noFill/>
+            <a:miter lim="800000"/>
+            <a:headEnd/>
+            <a:tailEnd/>
+          </a:ln>
+        </p:spPr>
+        <p:txBody>
+          <a:bodyPr vert="horz" wrap="square" lIns="91440" tIns="45720" rIns="91440" bIns="45720" numCol="1" anchor="t" anchorCtr="0" compatLnSpc="1">
+            <a:prstTxWarp prst="textNoShape">
+              <a:avLst/>
+            </a:prstTxWarp>
+          </a:bodyPr>
+          <a:lstStyle>
+            <a:lvl1pPr marL="0" indent="0" algn="l" rtl="0" eaLnBrk="0" fontAlgn="base" hangingPunct="0">
+              <a:spcBef>
+                <a:spcPct val="20000"/>
+              </a:spcBef>
+              <a:spcAft>
+                <a:spcPct val="0"/>
+              </a:spcAft>
+              <a:buNone/>
+              <a:defRPr sz="2000">
+                <a:solidFill>
+                  <a:schemeClr val="tx1"/>
+                </a:solidFill>
+                <a:latin typeface="+mn-lt"/>
+                <a:ea typeface="+mn-ea"/>
+                <a:cs typeface="+mn-cs"/>
+              </a:defRPr>
+            </a:lvl1pPr>
+            <a:lvl2pPr marL="457200" indent="0" algn="l" rtl="0" eaLnBrk="0" fontAlgn="base" hangingPunct="0">
+              <a:spcBef>
+                <a:spcPct val="20000"/>
+              </a:spcBef>
+              <a:spcAft>
+                <a:spcPct val="0"/>
+              </a:spcAft>
+              <a:buNone/>
+              <a:defRPr sz="1800">
+                <a:solidFill>
+                  <a:schemeClr val="tx1"/>
+                </a:solidFill>
+                <a:latin typeface="+mn-lt"/>
+                <a:ea typeface="+mn-ea"/>
+              </a:defRPr>
+            </a:lvl2pPr>
+            <a:lvl3pPr marL="914400" indent="0" algn="l" rtl="0" eaLnBrk="0" fontAlgn="base" hangingPunct="0">
+              <a:spcBef>
+                <a:spcPct val="20000"/>
+              </a:spcBef>
+              <a:spcAft>
+                <a:spcPct val="0"/>
+              </a:spcAft>
+              <a:buNone/>
+              <a:defRPr sz="1600">
+                <a:solidFill>
+                  <a:schemeClr val="tx1"/>
+                </a:solidFill>
+                <a:latin typeface="+mn-lt"/>
+                <a:ea typeface="+mn-ea"/>
+              </a:defRPr>
+            </a:lvl3pPr>
+            <a:lvl4pPr marL="1371600" indent="0" algn="l" rtl="0" eaLnBrk="0" fontAlgn="base" hangingPunct="0">
+              <a:spcBef>
+                <a:spcPct val="20000"/>
+              </a:spcBef>
+              <a:spcAft>
+                <a:spcPct val="0"/>
+              </a:spcAft>
+              <a:buNone/>
+              <a:defRPr sz="1400">
+                <a:solidFill>
+                  <a:schemeClr val="tx1"/>
+                </a:solidFill>
+                <a:latin typeface="+mn-lt"/>
+                <a:ea typeface="+mn-ea"/>
+              </a:defRPr>
+            </a:lvl4pPr>
+            <a:lvl5pPr marL="1828800" indent="0" algn="l" rtl="0" eaLnBrk="0" fontAlgn="base" hangingPunct="0">
+              <a:spcBef>
+                <a:spcPct val="20000"/>
+              </a:spcBef>
+              <a:spcAft>
+                <a:spcPct val="0"/>
+              </a:spcAft>
+              <a:buNone/>
+              <a:defRPr sz="1400">
+                <a:solidFill>
+                  <a:schemeClr val="tx1"/>
+                </a:solidFill>
+                <a:latin typeface="+mn-lt"/>
+                <a:ea typeface="+mn-ea"/>
+              </a:defRPr>
+            </a:lvl5pPr>
+            <a:lvl6pPr marL="2286000" indent="0" algn="l" rtl="0" fontAlgn="base">
+              <a:spcBef>
+                <a:spcPct val="20000"/>
+              </a:spcBef>
+              <a:spcAft>
+                <a:spcPct val="0"/>
+              </a:spcAft>
+              <a:buNone/>
+              <a:defRPr sz="1400">
+                <a:solidFill>
+                  <a:schemeClr val="tx1"/>
+                </a:solidFill>
+                <a:latin typeface="+mn-lt"/>
+                <a:ea typeface="+mn-ea"/>
+              </a:defRPr>
+            </a:lvl6pPr>
+            <a:lvl7pPr marL="2743200" indent="0" algn="l" rtl="0" fontAlgn="base">
+              <a:spcBef>
+                <a:spcPct val="20000"/>
+              </a:spcBef>
+              <a:spcAft>
+                <a:spcPct val="0"/>
+              </a:spcAft>
+              <a:buNone/>
+              <a:defRPr sz="1400">
+                <a:solidFill>
+                  <a:schemeClr val="tx1"/>
+                </a:solidFill>
+                <a:latin typeface="+mn-lt"/>
+                <a:ea typeface="+mn-ea"/>
+              </a:defRPr>
+            </a:lvl7pPr>
+            <a:lvl8pPr marL="3200400" indent="0" algn="l" rtl="0" fontAlgn="base">
+              <a:spcBef>
+                <a:spcPct val="20000"/>
+              </a:spcBef>
+              <a:spcAft>
+                <a:spcPct val="0"/>
+              </a:spcAft>
+              <a:buNone/>
+              <a:defRPr sz="1400">
+                <a:solidFill>
+                  <a:schemeClr val="tx1"/>
+                </a:solidFill>
+                <a:latin typeface="+mn-lt"/>
+                <a:ea typeface="+mn-ea"/>
+              </a:defRPr>
+            </a:lvl8pPr>
+            <a:lvl9pPr marL="3657600" indent="0" algn="l" rtl="0" fontAlgn="base">
+              <a:spcBef>
+                <a:spcPct val="20000"/>
+              </a:spcBef>
+              <a:spcAft>
+                <a:spcPct val="0"/>
+              </a:spcAft>
+              <a:buNone/>
+              <a:defRPr sz="1400">
+                <a:solidFill>
+                  <a:schemeClr val="tx1"/>
+                </a:solidFill>
+                <a:latin typeface="+mn-lt"/>
+                <a:ea typeface="+mn-ea"/>
+              </a:defRPr>
+            </a:lvl9pPr>
+          </a:lstStyle>
+          <a:p>
+            <a:pPr>
+              <a:lnSpc>
+                <a:spcPct val="100000"/>
+              </a:lnSpc>
+            </a:pPr>
+            <a:r>
+              <a:rPr lang="en-US" kern="0" dirty="0"/>
+              <a:t>=&gt; We use the interpreter pattern to interpret the formula in A3, and the observer pattern to observe the changes in A1 and A2.</a:t>
+            </a:r>
+          </a:p>
+        </p:txBody>
+      </p:sp>
+    </p:spTree>
+    <p:extLst>
+      <p:ext uri="{BB962C8B-B14F-4D97-AF65-F5344CB8AC3E}">
+        <p14:creationId xmlns:p14="http://schemas.microsoft.com/office/powerpoint/2010/main" val="2358784333"/>
       </p:ext>
     </p:extLst>
   </p:cSld>

</xml_diff>